<commit_message>
Updated the interim pptx
</commit_message>
<xml_diff>
--- a/Docs/Interim_Presentation_Saugat_Pokharel_3093315.pptx
+++ b/Docs/Interim_Presentation_Saugat_Pokharel_3093315.pptx
@@ -710,7 +710,7 @@
           <a:p>
             <a:fld id="{C764DE79-268F-4C1A-8933-263129D2AF90}" type="datetimeFigureOut">
               <a:rPr lang="en-US" smtClean="0"/>
-              <a:t>4/17/26</a:t>
+              <a:t>4/21/26</a:t>
             </a:fld>
             <a:endParaRPr lang="en-US" dirty="0"/>
           </a:p>
@@ -881,7 +881,7 @@
           <a:p>
             <a:fld id="{C764DE79-268F-4C1A-8933-263129D2AF90}" type="datetimeFigureOut">
               <a:rPr lang="en-US" smtClean="0"/>
-              <a:t>4/17/26</a:t>
+              <a:t>4/21/26</a:t>
             </a:fld>
             <a:endParaRPr lang="en-US" dirty="0"/>
           </a:p>
@@ -1062,7 +1062,7 @@
           <a:p>
             <a:fld id="{C764DE79-268F-4C1A-8933-263129D2AF90}" type="datetimeFigureOut">
               <a:rPr lang="en-US" smtClean="0"/>
-              <a:t>4/17/26</a:t>
+              <a:t>4/21/26</a:t>
             </a:fld>
             <a:endParaRPr lang="en-US" dirty="0"/>
           </a:p>
@@ -1268,7 +1268,7 @@
           <a:p>
             <a:fld id="{C764DE79-268F-4C1A-8933-263129D2AF90}" type="datetimeFigureOut">
               <a:rPr lang="en-US" smtClean="0"/>
-              <a:t>4/17/26</a:t>
+              <a:t>4/21/26</a:t>
             </a:fld>
             <a:endParaRPr lang="en-US" dirty="0"/>
           </a:p>
@@ -1515,7 +1515,7 @@
           <a:p>
             <a:fld id="{C764DE79-268F-4C1A-8933-263129D2AF90}" type="datetimeFigureOut">
               <a:rPr lang="en-US" smtClean="0"/>
-              <a:t>4/17/26</a:t>
+              <a:t>4/21/26</a:t>
             </a:fld>
             <a:endParaRPr lang="en-US" dirty="0"/>
           </a:p>
@@ -1748,7 +1748,7 @@
           <a:p>
             <a:fld id="{C764DE79-268F-4C1A-8933-263129D2AF90}" type="datetimeFigureOut">
               <a:rPr lang="en-US" smtClean="0"/>
-              <a:t>4/17/26</a:t>
+              <a:t>4/21/26</a:t>
             </a:fld>
             <a:endParaRPr lang="en-US" dirty="0"/>
           </a:p>
@@ -2116,7 +2116,7 @@
           <a:p>
             <a:fld id="{C764DE79-268F-4C1A-8933-263129D2AF90}" type="datetimeFigureOut">
               <a:rPr lang="en-US" smtClean="0"/>
-              <a:t>4/17/26</a:t>
+              <a:t>4/21/26</a:t>
             </a:fld>
             <a:endParaRPr lang="en-US" dirty="0"/>
           </a:p>
@@ -2235,7 +2235,7 @@
           <a:p>
             <a:fld id="{C764DE79-268F-4C1A-8933-263129D2AF90}" type="datetimeFigureOut">
               <a:rPr lang="en-US" smtClean="0"/>
-              <a:t>4/17/26</a:t>
+              <a:t>4/21/26</a:t>
             </a:fld>
             <a:endParaRPr lang="en-US" dirty="0"/>
           </a:p>
@@ -2331,7 +2331,7 @@
           <a:p>
             <a:fld id="{C764DE79-268F-4C1A-8933-263129D2AF90}" type="datetimeFigureOut">
               <a:rPr lang="en-US" smtClean="0"/>
-              <a:t>4/17/26</a:t>
+              <a:t>4/21/26</a:t>
             </a:fld>
             <a:endParaRPr lang="en-US" dirty="0"/>
           </a:p>
@@ -2609,7 +2609,7 @@
           <a:p>
             <a:fld id="{C764DE79-268F-4C1A-8933-263129D2AF90}" type="datetimeFigureOut">
               <a:rPr lang="en-US" smtClean="0"/>
-              <a:t>4/17/26</a:t>
+              <a:t>4/21/26</a:t>
             </a:fld>
             <a:endParaRPr lang="en-US" dirty="0"/>
           </a:p>
@@ -2867,7 +2867,7 @@
           <a:p>
             <a:fld id="{C764DE79-268F-4C1A-8933-263129D2AF90}" type="datetimeFigureOut">
               <a:rPr lang="en-US" smtClean="0"/>
-              <a:t>4/17/26</a:t>
+              <a:t>4/21/26</a:t>
             </a:fld>
             <a:endParaRPr lang="en-US" dirty="0"/>
           </a:p>
@@ -3081,7 +3081,7 @@
           <a:p>
             <a:fld id="{C764DE79-268F-4C1A-8933-263129D2AF90}" type="datetimeFigureOut">
               <a:rPr lang="en-US" smtClean="0"/>
-              <a:t>4/17/26</a:t>
+              <a:t>4/21/26</a:t>
             </a:fld>
             <a:endParaRPr lang="en-US" dirty="0"/>
           </a:p>
@@ -3530,36 +3530,6 @@
       </p:sp>
       <p:sp>
         <p:nvSpPr>
-          <p:cNvPr id="3" name="Shape 1"/>
-          <p:cNvSpPr/>
-          <p:nvPr/>
-        </p:nvSpPr>
-        <p:spPr>
-          <a:xfrm>
-            <a:off x="457200" y="2560320"/>
-            <a:ext cx="8229600" cy="0"/>
-          </a:xfrm>
-          <a:prstGeom prst="line">
-            <a:avLst/>
-          </a:prstGeom>
-          <a:noFill/>
-          <a:ln w="12700">
-            <a:solidFill>
-              <a:srgbClr val="028090"/>
-            </a:solidFill>
-            <a:prstDash val="sysDash"/>
-          </a:ln>
-        </p:spPr>
-        <p:txBody>
-          <a:bodyPr/>
-          <a:lstStyle/>
-          <a:p>
-            <a:endParaRPr lang="en-US"/>
-          </a:p>
-        </p:txBody>
-      </p:sp>
-      <p:sp>
-        <p:nvSpPr>
           <p:cNvPr id="4" name="Text 2"/>
           <p:cNvSpPr/>
           <p:nvPr/>
@@ -3663,7 +3633,7 @@
             <a:r>
               <a:rPr lang="en-US" sz="1400" dirty="0">
                 <a:solidFill>
-                  <a:srgbClr val="8899AA"/>
+                  <a:schemeClr val="bg1"/>
                 </a:solidFill>
                 <a:latin typeface="Calibri" pitchFamily="34" charset="0"/>
                 <a:ea typeface="Calibri" pitchFamily="34" charset="-122"/>
@@ -3671,7 +3641,11 @@
               </a:rPr>
               <a:t>Interim Presentation  |  BSc Computing — Final Year Project</a:t>
             </a:r>
-            <a:endParaRPr lang="en-US" sz="1400" dirty="0"/>
+            <a:endParaRPr lang="en-US" sz="1400" dirty="0">
+              <a:solidFill>
+                <a:schemeClr val="bg1"/>
+              </a:solidFill>
+            </a:endParaRPr>
           </a:p>
         </p:txBody>
       </p:sp>
@@ -3702,7 +3676,7 @@
             <a:r>
               <a:rPr lang="en-US" sz="1300" dirty="0">
                 <a:solidFill>
-                  <a:srgbClr val="8899AA"/>
+                  <a:schemeClr val="bg1"/>
                 </a:solidFill>
                 <a:latin typeface="Calibri" pitchFamily="34" charset="0"/>
                 <a:ea typeface="Calibri" pitchFamily="34" charset="-122"/>
@@ -3710,7 +3684,11 @@
               </a:rPr>
               <a:t>Saugat Pokharel  |  Student No: 3093315  |  Supervisor: Atif</a:t>
             </a:r>
-            <a:endParaRPr lang="en-US" sz="1300" dirty="0"/>
+            <a:endParaRPr lang="en-US" sz="1300" dirty="0">
+              <a:solidFill>
+                <a:schemeClr val="bg1"/>
+              </a:solidFill>
+            </a:endParaRPr>
           </a:p>
         </p:txBody>
       </p:sp>
@@ -3812,7 +3790,7 @@
             <a:r>
               <a:rPr lang="en-US" sz="1100" dirty="0">
                 <a:solidFill>
-                  <a:srgbClr val="8899AA"/>
+                  <a:schemeClr val="bg1"/>
                 </a:solidFill>
                 <a:latin typeface="Calibri" pitchFamily="34" charset="0"/>
                 <a:ea typeface="Calibri" pitchFamily="34" charset="-122"/>
@@ -3820,7 +3798,11 @@
               </a:rPr>
               <a:t>Dataset — 48 patients</a:t>
             </a:r>
-            <a:endParaRPr lang="en-US" sz="1100" dirty="0"/>
+            <a:endParaRPr lang="en-US" sz="1100" dirty="0">
+              <a:solidFill>
+                <a:schemeClr val="bg1"/>
+              </a:solidFill>
+            </a:endParaRPr>
           </a:p>
         </p:txBody>
       </p:sp>
@@ -3832,7 +3814,7 @@
         </p:nvSpPr>
         <p:spPr>
           <a:xfrm>
-            <a:off x="3749040" y="3840480"/>
+            <a:off x="3867574" y="3840480"/>
             <a:ext cx="2286000" cy="1005840"/>
           </a:xfrm>
           <a:prstGeom prst="rect">
@@ -3922,15 +3904,19 @@
             <a:r>
               <a:rPr lang="en-US" sz="1100" dirty="0">
                 <a:solidFill>
-                  <a:srgbClr val="8899AA"/>
+                  <a:schemeClr val="bg1"/>
                 </a:solidFill>
                 <a:latin typeface="Calibri" pitchFamily="34" charset="0"/>
                 <a:ea typeface="Calibri" pitchFamily="34" charset="-122"/>
                 <a:cs typeface="Calibri" pitchFamily="34" charset="-120"/>
               </a:rPr>
-              <a:t>Heartbeats — extracted</a:t>
-            </a:r>
-            <a:endParaRPr lang="en-US" sz="1100" dirty="0"/>
+              <a:t>Total Heartbeats extracted</a:t>
+            </a:r>
+            <a:endParaRPr lang="en-US" sz="1100" dirty="0">
+              <a:solidFill>
+                <a:schemeClr val="bg1"/>
+              </a:solidFill>
+            </a:endParaRPr>
           </a:p>
         </p:txBody>
       </p:sp>
@@ -4032,7 +4018,7 @@
             <a:r>
               <a:rPr lang="en-US" sz="1100" dirty="0">
                 <a:solidFill>
-                  <a:srgbClr val="8899AA"/>
+                  <a:schemeClr val="bg1"/>
                 </a:solidFill>
                 <a:latin typeface="Calibri" pitchFamily="34" charset="0"/>
                 <a:ea typeface="Calibri" pitchFamily="34" charset="-122"/>
@@ -4040,7 +4026,11 @@
               </a:rPr>
               <a:t>Technology — SHAP &amp; LIME</a:t>
             </a:r>
-            <a:endParaRPr lang="en-US" sz="1100" dirty="0"/>
+            <a:endParaRPr lang="en-US" sz="1100" dirty="0">
+              <a:solidFill>
+                <a:schemeClr val="bg1"/>
+              </a:solidFill>
+            </a:endParaRPr>
           </a:p>
         </p:txBody>
       </p:sp>
@@ -4256,7 +4246,7 @@
             <a:r>
               <a:rPr lang="en-US" sz="1100" b="1" dirty="0">
                 <a:solidFill>
-                  <a:srgbClr val="8899AA"/>
+                  <a:schemeClr val="bg1"/>
                 </a:solidFill>
                 <a:latin typeface="Calibri" pitchFamily="34" charset="0"/>
                 <a:ea typeface="Calibri" pitchFamily="34" charset="-122"/>
@@ -4264,7 +4254,11 @@
               </a:rPr>
               <a:t>Problem</a:t>
             </a:r>
-            <a:endParaRPr lang="en-US" sz="1100" dirty="0"/>
+            <a:endParaRPr lang="en-US" sz="1100" dirty="0">
+              <a:solidFill>
+                <a:schemeClr val="bg1"/>
+              </a:solidFill>
+            </a:endParaRPr>
           </a:p>
           <a:p>
             <a:pPr marL="0" indent="0">
@@ -4273,7 +4267,7 @@
             <a:r>
               <a:rPr lang="en-US" sz="1100" dirty="0">
                 <a:solidFill>
-                  <a:srgbClr val="8899AA"/>
+                  <a:schemeClr val="bg1"/>
                 </a:solidFill>
                 <a:latin typeface="Calibri" pitchFamily="34" charset="0"/>
                 <a:ea typeface="Calibri" pitchFamily="34" charset="-122"/>
@@ -4281,7 +4275,11 @@
               </a:rPr>
               <a:t>Cardiovascular disease is a leading cause of death worldwide. Manual ECG interpretation is slow and requires specialist knowledge.</a:t>
             </a:r>
-            <a:endParaRPr lang="en-US" sz="1100" dirty="0"/>
+            <a:endParaRPr lang="en-US" sz="1100" dirty="0">
+              <a:solidFill>
+                <a:schemeClr val="bg1"/>
+              </a:solidFill>
+            </a:endParaRPr>
           </a:p>
         </p:txBody>
       </p:sp>
@@ -4312,7 +4310,7 @@
             <a:r>
               <a:rPr lang="en-US" sz="1100" b="1" dirty="0">
                 <a:solidFill>
-                  <a:srgbClr val="8899AA"/>
+                  <a:schemeClr val="bg1"/>
                 </a:solidFill>
                 <a:latin typeface="Calibri" pitchFamily="34" charset="0"/>
                 <a:ea typeface="Calibri" pitchFamily="34" charset="-122"/>
@@ -4320,7 +4318,11 @@
               </a:rPr>
               <a:t>Solution</a:t>
             </a:r>
-            <a:endParaRPr lang="en-US" sz="1100" dirty="0"/>
+            <a:endParaRPr lang="en-US" sz="1100" dirty="0">
+              <a:solidFill>
+                <a:schemeClr val="bg1"/>
+              </a:solidFill>
+            </a:endParaRPr>
           </a:p>
           <a:p>
             <a:pPr marL="0" indent="0">
@@ -4329,13 +4331,24 @@
             <a:r>
               <a:rPr lang="en-US" sz="1100" dirty="0">
                 <a:solidFill>
-                  <a:srgbClr val="8899AA"/>
+                  <a:schemeClr val="bg1"/>
                 </a:solidFill>
                 <a:latin typeface="Calibri" pitchFamily="34" charset="0"/>
                 <a:ea typeface="Calibri" pitchFamily="34" charset="-122"/>
                 <a:cs typeface="Calibri" pitchFamily="34" charset="-120"/>
               </a:rPr>
-              <a:t>An automated ML system to classify heartbeats as Normal or Abnormal with explainable AI showing why each decision was made.</a:t>
+              <a:t>An automated ML system to classify heartbeats as Normal or Abnormal with explainable AI showing why each decision was made</a:t>
+            </a:r>
+            <a:r>
+              <a:rPr lang="en-US" sz="1100" dirty="0">
+                <a:solidFill>
+                  <a:srgbClr val="8899AA"/>
+                </a:solidFill>
+                <a:latin typeface="Calibri" pitchFamily="34" charset="0"/>
+                <a:ea typeface="Calibri" pitchFamily="34" charset="-122"/>
+                <a:cs typeface="Calibri" pitchFamily="34" charset="-120"/>
+              </a:rPr>
+              <a:t>.</a:t>
             </a:r>
             <a:endParaRPr lang="en-US" sz="1100" dirty="0"/>
           </a:p>
@@ -4516,9 +4529,6 @@
             </a:pPr>
             <a:r>
               <a:rPr lang="en-US" sz="1000" dirty="0">
-                <a:solidFill>
-                  <a:srgbClr val="445566"/>
-                </a:solidFill>
                 <a:latin typeface="Calibri" pitchFamily="34" charset="0"/>
                 <a:ea typeface="Calibri" pitchFamily="34" charset="-122"/>
                 <a:cs typeface="Calibri" pitchFamily="34" charset="-120"/>
@@ -4665,9 +4675,6 @@
             </a:pPr>
             <a:r>
               <a:rPr lang="en-US" sz="1000" dirty="0">
-                <a:solidFill>
-                  <a:srgbClr val="445566"/>
-                </a:solidFill>
                 <a:latin typeface="Calibri" pitchFamily="34" charset="0"/>
                 <a:ea typeface="Calibri" pitchFamily="34" charset="-122"/>
                 <a:cs typeface="Calibri" pitchFamily="34" charset="-120"/>
@@ -4814,9 +4821,6 @@
             </a:pPr>
             <a:r>
               <a:rPr lang="en-US" sz="1000" dirty="0">
-                <a:solidFill>
-                  <a:srgbClr val="445566"/>
-                </a:solidFill>
                 <a:latin typeface="Calibri" pitchFamily="34" charset="0"/>
                 <a:ea typeface="Calibri" pitchFamily="34" charset="-122"/>
                 <a:cs typeface="Calibri" pitchFamily="34" charset="-120"/>
@@ -4963,9 +4967,6 @@
             </a:pPr>
             <a:r>
               <a:rPr lang="en-US" sz="1000" dirty="0">
-                <a:solidFill>
-                  <a:srgbClr val="445566"/>
-                </a:solidFill>
                 <a:latin typeface="Calibri" pitchFamily="34" charset="0"/>
                 <a:ea typeface="Calibri" pitchFamily="34" charset="-122"/>
                 <a:cs typeface="Calibri" pitchFamily="34" charset="-120"/>
@@ -5112,9 +5113,6 @@
             </a:pPr>
             <a:r>
               <a:rPr lang="en-US" sz="1000" dirty="0">
-                <a:solidFill>
-                  <a:srgbClr val="445566"/>
-                </a:solidFill>
                 <a:latin typeface="Calibri" pitchFamily="34" charset="0"/>
                 <a:ea typeface="Calibri" pitchFamily="34" charset="-122"/>
                 <a:cs typeface="Calibri" pitchFamily="34" charset="-120"/>
@@ -5398,7 +5396,7 @@
             <a:r>
               <a:rPr lang="en-US" sz="1200" b="1" dirty="0">
                 <a:solidFill>
-                  <a:srgbClr val="02C39A"/>
+                  <a:srgbClr val="00B050"/>
                 </a:solidFill>
                 <a:latin typeface="Calibri" pitchFamily="34" charset="0"/>
                 <a:ea typeface="Calibri" pitchFamily="34" charset="-122"/>
@@ -5406,7 +5404,11 @@
               </a:rPr>
               <a:t>Phase 1 — Data Loading ✓</a:t>
             </a:r>
-            <a:endParaRPr lang="en-US" sz="1200" dirty="0"/>
+            <a:endParaRPr lang="en-US" sz="1200" dirty="0">
+              <a:solidFill>
+                <a:srgbClr val="00B050"/>
+              </a:solidFill>
+            </a:endParaRPr>
           </a:p>
         </p:txBody>
       </p:sp>
@@ -5438,7 +5440,7 @@
             <a:r>
               <a:rPr lang="en-US" sz="1000" dirty="0">
                 <a:solidFill>
-                  <a:srgbClr val="8899AA"/>
+                  <a:schemeClr val="bg1"/>
                 </a:solidFill>
                 <a:latin typeface="Calibri" pitchFamily="34" charset="0"/>
                 <a:ea typeface="Calibri" pitchFamily="34" charset="-122"/>
@@ -5446,7 +5448,11 @@
               </a:rPr>
               <a:t>Loaded MIT-BIH Arrhythmia Database (48 patients)</a:t>
             </a:r>
-            <a:endParaRPr lang="en-US" sz="1000" dirty="0"/>
+            <a:endParaRPr lang="en-US" sz="1000" dirty="0">
+              <a:solidFill>
+                <a:schemeClr val="bg1"/>
+              </a:solidFill>
+            </a:endParaRPr>
           </a:p>
         </p:txBody>
       </p:sp>
@@ -5478,7 +5484,7 @@
             <a:r>
               <a:rPr lang="en-US" sz="1000" dirty="0">
                 <a:solidFill>
-                  <a:srgbClr val="8899AA"/>
+                  <a:schemeClr val="bg1"/>
                 </a:solidFill>
                 <a:latin typeface="Calibri" pitchFamily="34" charset="0"/>
                 <a:ea typeface="Calibri" pitchFamily="34" charset="-122"/>
@@ -5486,7 +5492,11 @@
               </a:rPr>
               <a:t>Explored ECG signal structure — 360 Hz, 30 min recordings</a:t>
             </a:r>
-            <a:endParaRPr lang="en-US" sz="1000" dirty="0"/>
+            <a:endParaRPr lang="en-US" sz="1000" dirty="0">
+              <a:solidFill>
+                <a:schemeClr val="bg1"/>
+              </a:solidFill>
+            </a:endParaRPr>
           </a:p>
         </p:txBody>
       </p:sp>
@@ -5518,7 +5528,7 @@
             <a:r>
               <a:rPr lang="en-US" sz="1000" dirty="0">
                 <a:solidFill>
-                  <a:srgbClr val="8899AA"/>
+                  <a:schemeClr val="bg1"/>
                 </a:solidFill>
                 <a:latin typeface="Calibri" pitchFamily="34" charset="0"/>
                 <a:ea typeface="Calibri" pitchFamily="34" charset="-122"/>
@@ -5526,7 +5536,11 @@
               </a:rPr>
               <a:t>Identified 112,647 annotated heartbeats across database</a:t>
             </a:r>
-            <a:endParaRPr lang="en-US" sz="1000" dirty="0"/>
+            <a:endParaRPr lang="en-US" sz="1000" dirty="0">
+              <a:solidFill>
+                <a:schemeClr val="bg1"/>
+              </a:solidFill>
+            </a:endParaRPr>
           </a:p>
         </p:txBody>
       </p:sp>
@@ -5558,7 +5572,7 @@
             <a:r>
               <a:rPr lang="en-US" sz="1000" dirty="0">
                 <a:solidFill>
-                  <a:srgbClr val="8899AA"/>
+                  <a:schemeClr val="bg1"/>
                 </a:solidFill>
                 <a:latin typeface="Calibri" pitchFamily="34" charset="0"/>
                 <a:ea typeface="Calibri" pitchFamily="34" charset="-122"/>
@@ -5566,7 +5580,11 @@
               </a:rPr>
               <a:t>Discovered class imbalance: 66.6% Normal beats</a:t>
             </a:r>
-            <a:endParaRPr lang="en-US" sz="1000" dirty="0"/>
+            <a:endParaRPr lang="en-US" sz="1000" dirty="0">
+              <a:solidFill>
+                <a:schemeClr val="bg1"/>
+              </a:solidFill>
+            </a:endParaRPr>
           </a:p>
         </p:txBody>
       </p:sp>
@@ -5598,7 +5616,7 @@
             <a:r>
               <a:rPr lang="en-US" sz="1000" dirty="0">
                 <a:solidFill>
-                  <a:srgbClr val="8899AA"/>
+                  <a:schemeClr val="bg1"/>
                 </a:solidFill>
                 <a:latin typeface="Calibri" pitchFamily="34" charset="0"/>
                 <a:ea typeface="Calibri" pitchFamily="34" charset="-122"/>
@@ -5606,7 +5624,11 @@
               </a:rPr>
               <a:t>Visualised raw ECG signals with annotation markers</a:t>
             </a:r>
-            <a:endParaRPr lang="en-US" sz="1000" dirty="0"/>
+            <a:endParaRPr lang="en-US" sz="1000" dirty="0">
+              <a:solidFill>
+                <a:schemeClr val="bg1"/>
+              </a:solidFill>
+            </a:endParaRPr>
           </a:p>
         </p:txBody>
       </p:sp>
@@ -5638,7 +5660,7 @@
           <a:bodyPr/>
           <a:lstStyle/>
           <a:p>
-            <a:endParaRPr lang="en-US"/>
+            <a:endParaRPr lang="en-US" dirty="0"/>
           </a:p>
         </p:txBody>
       </p:sp>
@@ -5740,7 +5762,7 @@
             <a:r>
               <a:rPr lang="en-US" sz="1200" b="1" dirty="0">
                 <a:solidFill>
-                  <a:srgbClr val="02C39A"/>
+                  <a:srgbClr val="00B050"/>
                 </a:solidFill>
                 <a:latin typeface="Calibri" pitchFamily="34" charset="0"/>
                 <a:ea typeface="Calibri" pitchFamily="34" charset="-122"/>
@@ -5748,7 +5770,11 @@
               </a:rPr>
               <a:t>Phase 2 — Segmentation ✓</a:t>
             </a:r>
-            <a:endParaRPr lang="en-US" sz="1200" dirty="0"/>
+            <a:endParaRPr lang="en-US" sz="1200" dirty="0">
+              <a:solidFill>
+                <a:srgbClr val="00B050"/>
+              </a:solidFill>
+            </a:endParaRPr>
           </a:p>
         </p:txBody>
       </p:sp>
@@ -5780,7 +5806,7 @@
             <a:r>
               <a:rPr lang="en-US" sz="1000" dirty="0">
                 <a:solidFill>
-                  <a:srgbClr val="8899AA"/>
+                  <a:schemeClr val="bg1"/>
                 </a:solidFill>
                 <a:latin typeface="Calibri" pitchFamily="34" charset="0"/>
                 <a:ea typeface="Calibri" pitchFamily="34" charset="-122"/>
@@ -5788,7 +5814,11 @@
               </a:rPr>
               <a:t>Built segmentation function with 360-sample window per beat</a:t>
             </a:r>
-            <a:endParaRPr lang="en-US" sz="1000" dirty="0"/>
+            <a:endParaRPr lang="en-US" sz="1000" dirty="0">
+              <a:solidFill>
+                <a:schemeClr val="bg1"/>
+              </a:solidFill>
+            </a:endParaRPr>
           </a:p>
         </p:txBody>
       </p:sp>
@@ -5820,7 +5850,7 @@
             <a:r>
               <a:rPr lang="en-US" sz="1000" dirty="0">
                 <a:solidFill>
-                  <a:srgbClr val="8899AA"/>
+                  <a:schemeClr val="bg1"/>
                 </a:solidFill>
                 <a:latin typeface="Calibri" pitchFamily="34" charset="0"/>
                 <a:ea typeface="Calibri" pitchFamily="34" charset="-122"/>
@@ -5828,7 +5858,11 @@
               </a:rPr>
               <a:t>Extracted 102,382 individual heartbeats from all 48 records</a:t>
             </a:r>
-            <a:endParaRPr lang="en-US" sz="1000" dirty="0"/>
+            <a:endParaRPr lang="en-US" sz="1000" dirty="0">
+              <a:solidFill>
+                <a:schemeClr val="bg1"/>
+              </a:solidFill>
+            </a:endParaRPr>
           </a:p>
         </p:txBody>
       </p:sp>
@@ -5860,7 +5894,7 @@
             <a:r>
               <a:rPr lang="en-US" sz="1000" dirty="0">
                 <a:solidFill>
-                  <a:srgbClr val="8899AA"/>
+                  <a:schemeClr val="bg1"/>
                 </a:solidFill>
                 <a:latin typeface="Calibri" pitchFamily="34" charset="0"/>
                 <a:ea typeface="Calibri" pitchFamily="34" charset="-122"/>
@@ -5868,7 +5902,11 @@
               </a:rPr>
               <a:t>Filtered invalid rhythm markers and paced beats</a:t>
             </a:r>
-            <a:endParaRPr lang="en-US" sz="1000" dirty="0"/>
+            <a:endParaRPr lang="en-US" sz="1000" dirty="0">
+              <a:solidFill>
+                <a:schemeClr val="bg1"/>
+              </a:solidFill>
+            </a:endParaRPr>
           </a:p>
         </p:txBody>
       </p:sp>
@@ -5900,7 +5938,7 @@
             <a:r>
               <a:rPr lang="en-US" sz="1000" dirty="0">
                 <a:solidFill>
-                  <a:srgbClr val="8899AA"/>
+                  <a:schemeClr val="bg1"/>
                 </a:solidFill>
                 <a:latin typeface="Calibri" pitchFamily="34" charset="0"/>
                 <a:ea typeface="Calibri" pitchFamily="34" charset="-122"/>
@@ -5908,7 +5946,11 @@
               </a:rPr>
               <a:t>Created binary labels: Normal (75,011) vs Abnormal (27,371)</a:t>
             </a:r>
-            <a:endParaRPr lang="en-US" sz="1000" dirty="0"/>
+            <a:endParaRPr lang="en-US" sz="1000" dirty="0">
+              <a:solidFill>
+                <a:schemeClr val="bg1"/>
+              </a:solidFill>
+            </a:endParaRPr>
           </a:p>
         </p:txBody>
       </p:sp>
@@ -5940,7 +5982,7 @@
             <a:r>
               <a:rPr lang="en-US" sz="1000" dirty="0">
                 <a:solidFill>
-                  <a:srgbClr val="8899AA"/>
+                  <a:schemeClr val="bg1"/>
                 </a:solidFill>
                 <a:latin typeface="Calibri" pitchFamily="34" charset="0"/>
                 <a:ea typeface="Calibri" pitchFamily="34" charset="-122"/>
@@ -5948,7 +5990,11 @@
               </a:rPr>
               <a:t>Saved dataset as numpy arrays for Phase 3 onwards</a:t>
             </a:r>
-            <a:endParaRPr lang="en-US" sz="1000" dirty="0"/>
+            <a:endParaRPr lang="en-US" sz="1000" dirty="0">
+              <a:solidFill>
+                <a:schemeClr val="bg1"/>
+              </a:solidFill>
+            </a:endParaRPr>
           </a:p>
         </p:txBody>
       </p:sp>
@@ -6082,7 +6128,7 @@
             <a:r>
               <a:rPr lang="en-US" sz="1200" b="1" dirty="0">
                 <a:solidFill>
-                  <a:srgbClr val="FFFFFF"/>
+                  <a:srgbClr val="FFC000"/>
                 </a:solidFill>
                 <a:latin typeface="Calibri" pitchFamily="34" charset="0"/>
                 <a:ea typeface="Calibri" pitchFamily="34" charset="-122"/>
@@ -6090,7 +6136,11 @@
               </a:rPr>
               <a:t>Phase 3 — EDA &amp; Features</a:t>
             </a:r>
-            <a:endParaRPr lang="en-US" sz="1200" dirty="0"/>
+            <a:endParaRPr lang="en-US" sz="1200" dirty="0">
+              <a:solidFill>
+                <a:srgbClr val="FFC000"/>
+              </a:solidFill>
+            </a:endParaRPr>
           </a:p>
         </p:txBody>
       </p:sp>
@@ -6122,7 +6172,7 @@
             <a:r>
               <a:rPr lang="en-US" sz="1000" dirty="0">
                 <a:solidFill>
-                  <a:srgbClr val="8899AA"/>
+                  <a:schemeClr val="bg1"/>
                 </a:solidFill>
                 <a:latin typeface="Calibri" pitchFamily="34" charset="0"/>
                 <a:ea typeface="Calibri" pitchFamily="34" charset="-122"/>
@@ -6130,7 +6180,11 @@
               </a:rPr>
               <a:t>Loaded segmented dataset successfully</a:t>
             </a:r>
-            <a:endParaRPr lang="en-US" sz="1000" dirty="0"/>
+            <a:endParaRPr lang="en-US" sz="1000" dirty="0">
+              <a:solidFill>
+                <a:schemeClr val="bg1"/>
+              </a:solidFill>
+            </a:endParaRPr>
           </a:p>
         </p:txBody>
       </p:sp>
@@ -6162,7 +6216,7 @@
             <a:r>
               <a:rPr lang="en-US" sz="1000" dirty="0">
                 <a:solidFill>
-                  <a:srgbClr val="8899AA"/>
+                  <a:schemeClr val="bg1"/>
                 </a:solidFill>
                 <a:latin typeface="Calibri" pitchFamily="34" charset="0"/>
                 <a:ea typeface="Calibri" pitchFamily="34" charset="-122"/>
@@ -6170,7 +6224,11 @@
               </a:rPr>
               <a:t>Visualised average beat shape per class (N, L, R, V, A)</a:t>
             </a:r>
-            <a:endParaRPr lang="en-US" sz="1000" dirty="0"/>
+            <a:endParaRPr lang="en-US" sz="1000" dirty="0">
+              <a:solidFill>
+                <a:schemeClr val="bg1"/>
+              </a:solidFill>
+            </a:endParaRPr>
           </a:p>
         </p:txBody>
       </p:sp>
@@ -6202,7 +6260,7 @@
             <a:r>
               <a:rPr lang="en-US" sz="1000" dirty="0">
                 <a:solidFill>
-                  <a:srgbClr val="8899AA"/>
+                  <a:schemeClr val="bg1"/>
                 </a:solidFill>
                 <a:latin typeface="Calibri" pitchFamily="34" charset="0"/>
                 <a:ea typeface="Calibri" pitchFamily="34" charset="-122"/>
@@ -6210,7 +6268,11 @@
               </a:rPr>
               <a:t>Identified visual differences between beat types</a:t>
             </a:r>
-            <a:endParaRPr lang="en-US" sz="1000" dirty="0"/>
+            <a:endParaRPr lang="en-US" sz="1000" dirty="0">
+              <a:solidFill>
+                <a:schemeClr val="bg1"/>
+              </a:solidFill>
+            </a:endParaRPr>
           </a:p>
         </p:txBody>
       </p:sp>
@@ -6242,7 +6304,7 @@
             <a:r>
               <a:rPr lang="en-US" sz="1000" dirty="0">
                 <a:solidFill>
-                  <a:srgbClr val="8899AA"/>
+                  <a:schemeClr val="bg1"/>
                 </a:solidFill>
                 <a:latin typeface="Calibri" pitchFamily="34" charset="0"/>
                 <a:ea typeface="Calibri" pitchFamily="34" charset="-122"/>
@@ -6250,7 +6312,11 @@
               </a:rPr>
               <a:t>Feature extraction upcoming — statistical + signal features</a:t>
             </a:r>
-            <a:endParaRPr lang="en-US" sz="1000" dirty="0"/>
+            <a:endParaRPr lang="en-US" sz="1000" dirty="0">
+              <a:solidFill>
+                <a:schemeClr val="bg1"/>
+              </a:solidFill>
+            </a:endParaRPr>
           </a:p>
         </p:txBody>
       </p:sp>
@@ -6282,7 +6348,7 @@
             <a:r>
               <a:rPr lang="en-US" sz="1000" dirty="0">
                 <a:solidFill>
-                  <a:srgbClr val="8899AA"/>
+                  <a:schemeClr val="bg1"/>
                 </a:solidFill>
                 <a:latin typeface="Calibri" pitchFamily="34" charset="0"/>
                 <a:ea typeface="Calibri" pitchFamily="34" charset="-122"/>
@@ -6290,7 +6356,11 @@
               </a:rPr>
               <a:t>Dataset preparation for ML model training</a:t>
             </a:r>
-            <a:endParaRPr lang="en-US" sz="1000" dirty="0"/>
+            <a:endParaRPr lang="en-US" sz="1000" dirty="0">
+              <a:solidFill>
+                <a:schemeClr val="bg1"/>
+              </a:solidFill>
+            </a:endParaRPr>
           </a:p>
         </p:txBody>
       </p:sp>

</xml_diff>